<commit_message>
Electronics style X approved; L3 draft 2: native circuits, computed load line, elaborate colour-coded examples
- design/tokens.json: style X + givens palette g1..g4; FAMILY.md approved; decisions logged
- lib: circuits.py (native schematics between terminal points), plots.py (computed plots), kit.py givens()/
  solution()/gc(); eqn.py: \textcolor spans survive MML2OMML (sentinel runs)
- L3: drawings.py redraws symbols, large-signal and small-signal models, mirror, CS amp, switch, feedback amp;
  native load-line plot; examples 1 and 2 over 2 slides each with reasons per step and colour-coded givens;
  figures cropped into raw/ and enhanced; check.py extended; draft-1 X/Y files replaced by draft-2
- docs: CLAUDE.md, STATUS, lessons, review, lectures skill updated with the new rules

Co-Authored-By: Claude Opus 5.5 <noreply@anthropic.com>
</commit_message>
<xml_diff>
--- a/.build/eqtest/eqtest.pptx
+++ b/.build/eqtest/eqtest.pptx
@@ -3123,19 +3123,65 @@
                           <m:r>
                             <a:rPr lang="en-US" sz="4000" b="0">
                               <a:solidFill>
-                                <a:srgbClr val="1B2A3A"/>
+                                <a:srgbClr val="15241D"/>
                               </a:solidFill>
                               <a:latin typeface="Cambria Math"/>
                               <a:cs typeface="Cambria Math"/>
                             </a:rPr>
-                            <m:t>i</m:t>
+                            <m:t>V</m:t>
                           </m:r>
                         </m:e>
                         <m:sub>
                           <m:r>
                             <a:rPr lang="en-US" sz="4000" b="0">
                               <a:solidFill>
-                                <a:srgbClr val="1B2A3A"/>
+                                <a:srgbClr val="15241D"/>
+                              </a:solidFill>
+                              <a:latin typeface="Cambria Math"/>
+                              <a:cs typeface="Cambria Math"/>
+                            </a:rPr>
+                            <m:t>G</m:t>
+                          </m:r>
+                        </m:sub>
+                      </m:sSub>
+                      <m:r>
+                        <a:rPr lang="en-US" sz="4000" b="0">
+                          <a:solidFill>
+                            <a:srgbClr val="15241D"/>
+                          </a:solidFill>
+                          <a:latin typeface="Cambria Math"/>
+                          <a:cs typeface="Cambria Math"/>
+                        </a:rPr>
+                        <m:t>=</m:t>
+                      </m:r>
+                      <m:sSub>
+                        <m:e>
+                          <m:r>
+                            <a:rPr lang="en-US" sz="4000" b="1">
+                              <a:solidFill>
+                                <a:srgbClr val="1F6FA8"/>
+                              </a:solidFill>
+                              <a:latin typeface="Cambria Math"/>
+                              <a:cs typeface="Cambria Math"/>
+                            </a:rPr>
+                            <m:t>V</m:t>
+                          </m:r>
+                        </m:e>
+                        <m:sub>
+                          <m:r>
+                            <a:rPr lang="en-US" sz="4000" b="1">
+                              <a:solidFill>
+                                <a:srgbClr val="1F6FA8"/>
+                              </a:solidFill>
+                              <a:latin typeface="Cambria Math"/>
+                              <a:cs typeface="Cambria Math"/>
+                            </a:rPr>
+                            <m:t>D</m:t>
+                          </m:r>
+                          <m:r>
+                            <a:rPr lang="en-US" sz="4000" b="1">
+                              <a:solidFill>
+                                <a:srgbClr val="1F6FA8"/>
                               </a:solidFill>
                               <a:latin typeface="Cambria Math"/>
                               <a:cs typeface="Cambria Math"/>
@@ -3144,277 +3190,256 @@
                           </m:r>
                         </m:sub>
                       </m:sSub>
+                      <m:f>
+                        <m:fPr>
+                          <m:type m:val="bar"/>
+                        </m:fPr>
+                        <m:num>
+                          <m:sSub>
+                            <m:e>
+                              <m:r>
+                                <a:rPr lang="en-US" sz="4000" b="1">
+                                  <a:solidFill>
+                                    <a:srgbClr val="7A3E9D"/>
+                                  </a:solidFill>
+                                  <a:latin typeface="Cambria Math"/>
+                                  <a:cs typeface="Cambria Math"/>
+                                </a:rPr>
+                                <m:t>R</m:t>
+                              </m:r>
+                            </m:e>
+                            <m:sub>
+                              <m:r>
+                                <a:rPr lang="en-US" sz="4000" b="1">
+                                  <a:solidFill>
+                                    <a:srgbClr val="7A3E9D"/>
+                                  </a:solidFill>
+                                  <a:latin typeface="Cambria Math"/>
+                                  <a:cs typeface="Cambria Math"/>
+                                </a:rPr>
+                                <m:t>G</m:t>
+                              </m:r>
+                              <m:r>
+                                <m:rPr>
+                                  <m:sty m:val="p"/>
+                                </m:rPr>
+                                <a:rPr lang="en-US" sz="4000" b="1">
+                                  <a:solidFill>
+                                    <a:srgbClr val="7A3E9D"/>
+                                  </a:solidFill>
+                                  <a:latin typeface="Cambria Math"/>
+                                  <a:cs typeface="Cambria Math"/>
+                                </a:rPr>
+                                <m:t>2</m:t>
+                              </m:r>
+                            </m:sub>
+                          </m:sSub>
+                        </m:num>
+                        <m:den>
+                          <m:sSub>
+                            <m:e>
+                              <m:r>
+                                <a:rPr lang="en-US" sz="4000" b="1">
+                                  <a:solidFill>
+                                    <a:srgbClr val="7A3E9D"/>
+                                  </a:solidFill>
+                                  <a:latin typeface="Cambria Math"/>
+                                  <a:cs typeface="Cambria Math"/>
+                                </a:rPr>
+                                <m:t>R</m:t>
+                              </m:r>
+                            </m:e>
+                            <m:sub>
+                              <m:r>
+                                <a:rPr lang="en-US" sz="4000" b="1">
+                                  <a:solidFill>
+                                    <a:srgbClr val="7A3E9D"/>
+                                  </a:solidFill>
+                                  <a:latin typeface="Cambria Math"/>
+                                  <a:cs typeface="Cambria Math"/>
+                                </a:rPr>
+                                <m:t>G</m:t>
+                              </m:r>
+                              <m:r>
+                                <m:rPr>
+                                  <m:sty m:val="p"/>
+                                </m:rPr>
+                                <a:rPr lang="en-US" sz="4000" b="1">
+                                  <a:solidFill>
+                                    <a:srgbClr val="7A3E9D"/>
+                                  </a:solidFill>
+                                  <a:latin typeface="Cambria Math"/>
+                                  <a:cs typeface="Cambria Math"/>
+                                </a:rPr>
+                                <m:t>1</m:t>
+                              </m:r>
+                            </m:sub>
+                          </m:sSub>
+                          <m:r>
+                            <a:rPr lang="en-US" sz="4000" b="0">
+                              <a:solidFill>
+                                <a:srgbClr val="15241D"/>
+                              </a:solidFill>
+                              <a:latin typeface="Cambria Math"/>
+                              <a:cs typeface="Cambria Math"/>
+                            </a:rPr>
+                            <m:t>+</m:t>
+                          </m:r>
+                          <m:sSub>
+                            <m:e>
+                              <m:r>
+                                <a:rPr lang="en-US" sz="4000" b="1">
+                                  <a:solidFill>
+                                    <a:srgbClr val="7A3E9D"/>
+                                  </a:solidFill>
+                                  <a:latin typeface="Cambria Math"/>
+                                  <a:cs typeface="Cambria Math"/>
+                                </a:rPr>
+                                <m:t>R</m:t>
+                              </m:r>
+                            </m:e>
+                            <m:sub>
+                              <m:r>
+                                <a:rPr lang="en-US" sz="4000" b="1">
+                                  <a:solidFill>
+                                    <a:srgbClr val="7A3E9D"/>
+                                  </a:solidFill>
+                                  <a:latin typeface="Cambria Math"/>
+                                  <a:cs typeface="Cambria Math"/>
+                                </a:rPr>
+                                <m:t>G</m:t>
+                              </m:r>
+                              <m:r>
+                                <m:rPr>
+                                  <m:sty m:val="p"/>
+                                </m:rPr>
+                                <a:rPr lang="en-US" sz="4000" b="1">
+                                  <a:solidFill>
+                                    <a:srgbClr val="7A3E9D"/>
+                                  </a:solidFill>
+                                  <a:latin typeface="Cambria Math"/>
+                                  <a:cs typeface="Cambria Math"/>
+                                </a:rPr>
+                                <m:t>2</m:t>
+                              </m:r>
+                            </m:sub>
+                          </m:sSub>
+                        </m:den>
+                      </m:f>
                       <m:r>
                         <a:rPr lang="en-US" sz="4000" b="0">
                           <a:solidFill>
-                            <a:srgbClr val="1B2A3A"/>
+                            <a:srgbClr val="15241D"/>
                           </a:solidFill>
                           <a:latin typeface="Cambria Math"/>
                           <a:cs typeface="Cambria Math"/>
                         </a:rPr>
                         <m:t>=</m:t>
                       </m:r>
-                      <m:sSubSup>
-                        <m:e>
-                          <m:r>
-                            <a:rPr lang="en-US" sz="4000" b="0">
-                              <a:solidFill>
-                                <a:srgbClr val="1B2A3A"/>
-                              </a:solidFill>
-                              <a:latin typeface="Cambria Math"/>
-                              <a:cs typeface="Cambria Math"/>
-                            </a:rPr>
-                            <m:t>k</m:t>
-                          </m:r>
-                        </m:e>
-                        <m:sub>
-                          <m:r>
-                            <a:rPr lang="en-US" sz="4000" b="0">
-                              <a:solidFill>
-                                <a:srgbClr val="1B2A3A"/>
-                              </a:solidFill>
-                              <a:latin typeface="Cambria Math"/>
-                              <a:cs typeface="Cambria Math"/>
-                            </a:rPr>
-                            <m:t>n</m:t>
-                          </m:r>
-                        </m:sub>
-                        <m:sup>
-                          <m:r>
-                            <a:rPr lang="en-US" sz="4000" b="0">
-                              <a:solidFill>
-                                <a:srgbClr val="1B2A3A"/>
-                              </a:solidFill>
-                              <a:latin typeface="Cambria Math"/>
-                              <a:cs typeface="Cambria Math"/>
-                            </a:rPr>
-                            <m:t>′</m:t>
-                          </m:r>
-                        </m:sup>
-                      </m:sSubSup>
+                      <m:r>
+                        <m:rPr>
+                          <m:sty m:val="p"/>
+                        </m:rPr>
+                        <a:rPr lang="en-US" sz="4000" b="1">
+                          <a:solidFill>
+                            <a:srgbClr val="1F6FA8"/>
+                          </a:solidFill>
+                          <a:latin typeface="Cambria Math"/>
+                          <a:cs typeface="Cambria Math"/>
+                        </a:rPr>
+                        <m:t>10</m:t>
+                      </m:r>
+                      <m:r>
+                        <a:rPr lang="en-US" sz="4000" b="0">
+                          <a:solidFill>
+                            <a:srgbClr val="15241D"/>
+                          </a:solidFill>
+                          <a:latin typeface="Cambria Math"/>
+                          <a:cs typeface="Cambria Math"/>
+                        </a:rPr>
+                        <m:t>·</m:t>
+                      </m:r>
                       <m:f>
                         <m:fPr>
                           <m:type m:val="bar"/>
                         </m:fPr>
                         <m:num>
                           <m:r>
-                            <a:rPr lang="en-US" sz="4000" b="0">
+                            <m:rPr>
+                              <m:sty m:val="p"/>
+                            </m:rPr>
+                            <a:rPr lang="en-US" sz="4000" b="1">
                               <a:solidFill>
-                                <a:srgbClr val="1B2A3A"/>
+                                <a:srgbClr val="7A3E9D"/>
                               </a:solidFill>
                               <a:latin typeface="Cambria Math"/>
                               <a:cs typeface="Cambria Math"/>
                             </a:rPr>
-                            <m:t>W</m:t>
+                            <m:t>10</m:t>
                           </m:r>
                         </m:num>
                         <m:den>
                           <m:r>
-                            <a:rPr lang="en-US" sz="4000" b="0">
+                            <m:rPr>
+                              <m:sty m:val="p"/>
+                            </m:rPr>
+                            <a:rPr lang="en-US" sz="4000" b="1">
                               <a:solidFill>
-                                <a:srgbClr val="1B2A3A"/>
+                                <a:srgbClr val="7A3E9D"/>
                               </a:solidFill>
                               <a:latin typeface="Cambria Math"/>
                               <a:cs typeface="Cambria Math"/>
                             </a:rPr>
-                            <m:t>L</m:t>
+                            <m:t>10</m:t>
                           </m:r>
-                        </m:den>
-                      </m:f>
-                      <m:d>
-                        <m:dPr>
-                          <m:begChr m:val="["/>
-                          <m:sepChr m:val=""/>
-                          <m:endChr m:val="]"/>
-                        </m:dPr>
-                        <m:e>
                           <m:r>
                             <a:rPr lang="en-US" sz="4000" b="0">
                               <a:solidFill>
-                                <a:srgbClr val="1B2A3A"/>
+                                <a:srgbClr val="15241D"/>
                               </a:solidFill>
                               <a:latin typeface="Cambria Math"/>
                               <a:cs typeface="Cambria Math"/>
                             </a:rPr>
-                            <m:t>(</m:t>
+                            <m:t>+</m:t>
                           </m:r>
-                          <m:sSub>
-                            <m:e>
-                              <m:r>
-                                <a:rPr lang="en-US" sz="4000" b="0">
-                                  <a:solidFill>
-                                    <a:srgbClr val="1B2A3A"/>
-                                  </a:solidFill>
-                                  <a:latin typeface="Cambria Math"/>
-                                  <a:cs typeface="Cambria Math"/>
-                                </a:rPr>
-                                <m:t>v</m:t>
-                              </m:r>
-                            </m:e>
-                            <m:sub>
-                              <m:r>
-                                <a:rPr lang="en-US" sz="4000" b="0">
-                                  <a:solidFill>
-                                    <a:srgbClr val="1B2A3A"/>
-                                  </a:solidFill>
-                                  <a:latin typeface="Cambria Math"/>
-                                  <a:cs typeface="Cambria Math"/>
-                                </a:rPr>
-                                <m:t>GS</m:t>
-                              </m:r>
-                            </m:sub>
-                          </m:sSub>
                           <m:r>
-                            <a:rPr lang="en-US" sz="4000" b="0">
+                            <m:rPr>
+                              <m:sty m:val="p"/>
+                            </m:rPr>
+                            <a:rPr lang="en-US" sz="4000" b="1">
                               <a:solidFill>
-                                <a:srgbClr val="1B2A3A"/>
+                                <a:srgbClr val="7A3E9D"/>
                               </a:solidFill>
                               <a:latin typeface="Cambria Math"/>
                               <a:cs typeface="Cambria Math"/>
                             </a:rPr>
-                            <m:t>−</m:t>
+                            <m:t>10</m:t>
                           </m:r>
-                          <m:sSub>
-                            <m:e>
-                              <m:r>
-                                <a:rPr lang="en-US" sz="4000" b="0">
-                                  <a:solidFill>
-                                    <a:srgbClr val="1B2A3A"/>
-                                  </a:solidFill>
-                                  <a:latin typeface="Cambria Math"/>
-                                  <a:cs typeface="Cambria Math"/>
-                                </a:rPr>
-                                <m:t>V</m:t>
-                              </m:r>
-                            </m:e>
-                            <m:sub>
-                              <m:r>
-                                <a:rPr lang="en-US" sz="4000" b="0">
-                                  <a:solidFill>
-                                    <a:srgbClr val="1B2A3A"/>
-                                  </a:solidFill>
-                                  <a:latin typeface="Cambria Math"/>
-                                  <a:cs typeface="Cambria Math"/>
-                                </a:rPr>
-                                <m:t>t</m:t>
-                              </m:r>
-                            </m:sub>
-                          </m:sSub>
-                          <m:r>
-                            <a:rPr lang="en-US" sz="4000" b="0">
-                              <a:solidFill>
-                                <a:srgbClr val="1B2A3A"/>
-                              </a:solidFill>
-                              <a:latin typeface="Cambria Math"/>
-                              <a:cs typeface="Cambria Math"/>
-                            </a:rPr>
-                            <m:t>)</m:t>
-                          </m:r>
-                          <m:sSub>
-                            <m:e>
-                              <m:r>
-                                <a:rPr lang="en-US" sz="4000" b="0">
-                                  <a:solidFill>
-                                    <a:srgbClr val="1B2A3A"/>
-                                  </a:solidFill>
-                                  <a:latin typeface="Cambria Math"/>
-                                  <a:cs typeface="Cambria Math"/>
-                                </a:rPr>
-                                <m:t>v</m:t>
-                              </m:r>
-                            </m:e>
-                            <m:sub>
-                              <m:r>
-                                <a:rPr lang="en-US" sz="4000" b="0">
-                                  <a:solidFill>
-                                    <a:srgbClr val="1B2A3A"/>
-                                  </a:solidFill>
-                                  <a:latin typeface="Cambria Math"/>
-                                  <a:cs typeface="Cambria Math"/>
-                                </a:rPr>
-                                <m:t>DS</m:t>
-                              </m:r>
-                            </m:sub>
-                          </m:sSub>
-                          <m:r>
-                            <a:rPr lang="en-US" sz="4000" b="0">
-                              <a:solidFill>
-                                <a:srgbClr val="1B2A3A"/>
-                              </a:solidFill>
-                              <a:latin typeface="Cambria Math"/>
-                              <a:cs typeface="Cambria Math"/>
-                            </a:rPr>
-                            <m:t>−</m:t>
-                          </m:r>
-                          <m:f>
-                            <m:fPr>
-                              <m:type m:val="bar"/>
-                            </m:fPr>
-                            <m:num>
-                              <m:r>
-                                <a:rPr lang="en-US" sz="4000" b="0">
-                                  <a:solidFill>
-                                    <a:srgbClr val="1B2A3A"/>
-                                  </a:solidFill>
-                                  <a:latin typeface="Cambria Math"/>
-                                  <a:cs typeface="Cambria Math"/>
-                                </a:rPr>
-                                <m:t>1</m:t>
-                              </m:r>
-                            </m:num>
-                            <m:den>
-                              <m:r>
-                                <a:rPr lang="en-US" sz="4000" b="0">
-                                  <a:solidFill>
-                                    <a:srgbClr val="1B2A3A"/>
-                                  </a:solidFill>
-                                  <a:latin typeface="Cambria Math"/>
-                                  <a:cs typeface="Cambria Math"/>
-                                </a:rPr>
-                                <m:t>2</m:t>
-                              </m:r>
-                            </m:den>
-                          </m:f>
-                          <m:sSubSup>
-                            <m:e>
-                              <m:r>
-                                <a:rPr lang="en-US" sz="4000" b="0">
-                                  <a:solidFill>
-                                    <a:srgbClr val="1B2A3A"/>
-                                  </a:solidFill>
-                                  <a:latin typeface="Cambria Math"/>
-                                  <a:cs typeface="Cambria Math"/>
-                                </a:rPr>
-                                <m:t>v</m:t>
-                              </m:r>
-                            </m:e>
-                            <m:sub>
-                              <m:r>
-                                <a:rPr lang="en-US" sz="4000" b="0">
-                                  <a:solidFill>
-                                    <a:srgbClr val="1B2A3A"/>
-                                  </a:solidFill>
-                                  <a:latin typeface="Cambria Math"/>
-                                  <a:cs typeface="Cambria Math"/>
-                                </a:rPr>
-                                <m:t>DS</m:t>
-                              </m:r>
-                            </m:sub>
-                            <m:sup>
-                              <m:r>
-                                <a:rPr lang="en-US" sz="4000" b="0">
-                                  <a:solidFill>
-                                    <a:srgbClr val="1B2A3A"/>
-                                  </a:solidFill>
-                                  <a:latin typeface="Cambria Math"/>
-                                  <a:cs typeface="Cambria Math"/>
-                                </a:rPr>
-                                <m:t>2</m:t>
-                              </m:r>
-                            </m:sup>
-                          </m:sSubSup>
-                        </m:e>
-                      </m:d>
+                        </m:den>
+                      </m:f>
+                      <m:r>
+                        <a:rPr lang="en-US" sz="4000" b="0">
+                          <a:solidFill>
+                            <a:srgbClr val="15241D"/>
+                          </a:solidFill>
+                          <a:latin typeface="Cambria Math"/>
+                          <a:cs typeface="Cambria Math"/>
+                        </a:rPr>
+                        <m:t>=5</m:t>
+                      </m:r>
+                      <m:r>
+                        <m:rPr>
+                          <m:sty m:val="p"/>
+                        </m:rPr>
+                        <a:rPr lang="en-US" sz="4000" b="0">
+                          <a:solidFill>
+                            <a:srgbClr val="15241D"/>
+                          </a:solidFill>
+                          <a:latin typeface="Cambria Math"/>
+                          <a:cs typeface="Cambria Math"/>
+                        </a:rPr>
+                        <m:t> V</m:t>
+                      </m:r>
                     </m:oMath>
                   </m:oMathPara>
                 </a14:m>
@@ -3446,7 +3471,7 @@
               <a:lstStyle/>
               <a:p>
                 <a:r>
-                  <a:t>i_D = k_n' \frac{W}{L}\left[(v_{GS}-V_t)\,v_{DS} - \frac{1}{2}v_{DS}^2\right]</a:t>
+                  <a:t>V_G = \textcolor{#1F6FA8}{V_{DD}}\,\frac{\textcolor{#7A3E9D}{R_{G2}}}{\textcolor{#7A3E9D}{R_{G1}}+\textcolor{#7A3E9D}{R_{G2}}} = \textcolor{#1F6FA8}{10}\cdot\frac{\textcolor{#7A3E9D}{10}}{\textcolor{#7A3E9D}{10}+\textcolor{#7A3E9D}{10}} = 5\ \mathrm{V}</a:t>
                 </a:r>
               </a:p>
             </p:txBody>
@@ -3488,19 +3513,19 @@
                           <m:r>
                             <a:rPr lang="en-US" sz="4000" b="0">
                               <a:solidFill>
-                                <a:srgbClr val="1B2A3A"/>
+                                <a:srgbClr val="15241D"/>
                               </a:solidFill>
                               <a:latin typeface="Cambria Math"/>
                               <a:cs typeface="Cambria Math"/>
                             </a:rPr>
-                            <m:t>i</m:t>
+                            <m:t>I</m:t>
                           </m:r>
                         </m:e>
                         <m:sub>
                           <m:r>
                             <a:rPr lang="en-US" sz="4000" b="0">
                               <a:solidFill>
-                                <a:srgbClr val="1B2A3A"/>
+                                <a:srgbClr val="15241D"/>
                               </a:solidFill>
                               <a:latin typeface="Cambria Math"/>
                               <a:cs typeface="Cambria Math"/>
@@ -3512,7 +3537,7 @@
                       <m:r>
                         <a:rPr lang="en-US" sz="4000" b="0">
                           <a:solidFill>
-                            <a:srgbClr val="1B2A3A"/>
+                            <a:srgbClr val="15241D"/>
                           </a:solidFill>
                           <a:latin typeface="Cambria Math"/>
                           <a:cs typeface="Cambria Math"/>
@@ -3527,7 +3552,7 @@
                           <m:r>
                             <a:rPr lang="en-US" sz="4000" b="0">
                               <a:solidFill>
-                                <a:srgbClr val="1B2A3A"/>
+                                <a:srgbClr val="15241D"/>
                               </a:solidFill>
                               <a:latin typeface="Cambria Math"/>
                               <a:cs typeface="Cambria Math"/>
@@ -3539,7 +3564,7 @@
                           <m:r>
                             <a:rPr lang="en-US" sz="4000" b="0">
                               <a:solidFill>
-                                <a:srgbClr val="1B2A3A"/>
+                                <a:srgbClr val="15241D"/>
                               </a:solidFill>
                               <a:latin typeface="Cambria Math"/>
                               <a:cs typeface="Cambria Math"/>
@@ -3548,151 +3573,97 @@
                           </m:r>
                         </m:den>
                       </m:f>
-                      <m:sSubSup>
+                      <m:r>
+                        <m:rPr>
+                          <m:sty m:val="p"/>
+                        </m:rPr>
+                        <a:rPr lang="en-US" sz="4000" b="1">
+                          <a:solidFill>
+                            <a:srgbClr val="1E7A46"/>
+                          </a:solidFill>
+                          <a:latin typeface="Cambria Math"/>
+                          <a:cs typeface="Cambria Math"/>
+                        </a:rPr>
+                        <m:t>1</m:t>
+                      </m:r>
+                      <m:r>
+                        <a:rPr lang="en-US" sz="4000" b="0">
+                          <a:solidFill>
+                            <a:srgbClr val="15241D"/>
+                          </a:solidFill>
+                          <a:latin typeface="Cambria Math"/>
+                          <a:cs typeface="Cambria Math"/>
+                        </a:rPr>
+                        <m:t>(5−</m:t>
+                      </m:r>
+                      <m:r>
+                        <m:rPr>
+                          <m:sty m:val="p"/>
+                        </m:rPr>
+                        <a:rPr lang="en-US" sz="4000" b="1">
+                          <a:solidFill>
+                            <a:srgbClr val="7A3E9D"/>
+                          </a:solidFill>
+                          <a:latin typeface="Cambria Math"/>
+                          <a:cs typeface="Cambria Math"/>
+                        </a:rPr>
+                        <m:t>6</m:t>
+                      </m:r>
+                      <m:sSub>
                         <m:e>
                           <m:r>
                             <a:rPr lang="en-US" sz="4000" b="0">
                               <a:solidFill>
-                                <a:srgbClr val="1B2A3A"/>
+                                <a:srgbClr val="15241D"/>
                               </a:solidFill>
                               <a:latin typeface="Cambria Math"/>
                               <a:cs typeface="Cambria Math"/>
                             </a:rPr>
-                            <m:t>k</m:t>
+                            <m:t>I</m:t>
                           </m:r>
                         </m:e>
                         <m:sub>
                           <m:r>
                             <a:rPr lang="en-US" sz="4000" b="0">
                               <a:solidFill>
-                                <a:srgbClr val="1B2A3A"/>
+                                <a:srgbClr val="15241D"/>
                               </a:solidFill>
                               <a:latin typeface="Cambria Math"/>
                               <a:cs typeface="Cambria Math"/>
                             </a:rPr>
-                            <m:t>n</m:t>
-                          </m:r>
-                        </m:sub>
-                        <m:sup>
-                          <m:r>
-                            <a:rPr lang="en-US" sz="4000" b="0">
-                              <a:solidFill>
-                                <a:srgbClr val="1B2A3A"/>
-                              </a:solidFill>
-                              <a:latin typeface="Cambria Math"/>
-                              <a:cs typeface="Cambria Math"/>
-                            </a:rPr>
-                            <m:t>′</m:t>
-                          </m:r>
-                        </m:sup>
-                      </m:sSubSup>
-                      <m:f>
-                        <m:fPr>
-                          <m:type m:val="bar"/>
-                        </m:fPr>
-                        <m:num>
-                          <m:r>
-                            <a:rPr lang="en-US" sz="4000" b="0">
-                              <a:solidFill>
-                                <a:srgbClr val="1B2A3A"/>
-                              </a:solidFill>
-                              <a:latin typeface="Cambria Math"/>
-                              <a:cs typeface="Cambria Math"/>
-                            </a:rPr>
-                            <m:t>W</m:t>
-                          </m:r>
-                        </m:num>
-                        <m:den>
-                          <m:r>
-                            <a:rPr lang="en-US" sz="4000" b="0">
-                              <a:solidFill>
-                                <a:srgbClr val="1B2A3A"/>
-                              </a:solidFill>
-                              <a:latin typeface="Cambria Math"/>
-                              <a:cs typeface="Cambria Math"/>
-                            </a:rPr>
-                            <m:t>L</m:t>
-                          </m:r>
-                        </m:den>
-                      </m:f>
-                      <m:r>
-                        <a:rPr lang="en-US" sz="4000" b="0">
-                          <a:solidFill>
-                            <a:srgbClr val="1B2A3A"/>
-                          </a:solidFill>
-                          <a:latin typeface="Cambria Math"/>
-                          <a:cs typeface="Cambria Math"/>
-                        </a:rPr>
-                        <m:t>(</m:t>
-                      </m:r>
-                      <m:sSub>
-                        <m:e>
-                          <m:r>
-                            <a:rPr lang="en-US" sz="4000" b="0">
-                              <a:solidFill>
-                                <a:srgbClr val="1B2A3A"/>
-                              </a:solidFill>
-                              <a:latin typeface="Cambria Math"/>
-                              <a:cs typeface="Cambria Math"/>
-                            </a:rPr>
-                            <m:t>v</m:t>
-                          </m:r>
-                        </m:e>
-                        <m:sub>
-                          <m:r>
-                            <a:rPr lang="en-US" sz="4000" b="0">
-                              <a:solidFill>
-                                <a:srgbClr val="1B2A3A"/>
-                              </a:solidFill>
-                              <a:latin typeface="Cambria Math"/>
-                              <a:cs typeface="Cambria Math"/>
-                            </a:rPr>
-                            <m:t>GS</m:t>
+                            <m:t>D</m:t>
                           </m:r>
                         </m:sub>
                       </m:sSub>
                       <m:r>
                         <a:rPr lang="en-US" sz="4000" b="0">
                           <a:solidFill>
-                            <a:srgbClr val="1B2A3A"/>
+                            <a:srgbClr val="15241D"/>
                           </a:solidFill>
                           <a:latin typeface="Cambria Math"/>
                           <a:cs typeface="Cambria Math"/>
                         </a:rPr>
                         <m:t>−</m:t>
                       </m:r>
-                      <m:sSub>
-                        <m:e>
-                          <m:r>
-                            <a:rPr lang="en-US" sz="4000" b="0">
-                              <a:solidFill>
-                                <a:srgbClr val="1B2A3A"/>
-                              </a:solidFill>
-                              <a:latin typeface="Cambria Math"/>
-                              <a:cs typeface="Cambria Math"/>
-                            </a:rPr>
-                            <m:t>V</m:t>
-                          </m:r>
-                        </m:e>
-                        <m:sub>
-                          <m:r>
-                            <a:rPr lang="en-US" sz="4000" b="0">
-                              <a:solidFill>
-                                <a:srgbClr val="1B2A3A"/>
-                              </a:solidFill>
-                              <a:latin typeface="Cambria Math"/>
-                              <a:cs typeface="Cambria Math"/>
-                            </a:rPr>
-                            <m:t>t</m:t>
-                          </m:r>
-                        </m:sub>
-                      </m:sSub>
+                      <m:r>
+                        <m:rPr>
+                          <m:sty m:val="p"/>
+                        </m:rPr>
+                        <a:rPr lang="en-US" sz="4000" b="1">
+                          <a:solidFill>
+                            <a:srgbClr val="1E7A46"/>
+                          </a:solidFill>
+                          <a:latin typeface="Cambria Math"/>
+                          <a:cs typeface="Cambria Math"/>
+                        </a:rPr>
+                        <m:t>1</m:t>
+                      </m:r>
                       <m:sSup>
                         <m:e>
                           <m:r>
                             <a:rPr lang="en-US" sz="4000" b="0">
                               <a:solidFill>
-                                <a:srgbClr val="1B2A3A"/>
+                                <a:srgbClr val="15241D"/>
                               </a:solidFill>
                               <a:latin typeface="Cambria Math"/>
                               <a:cs typeface="Cambria Math"/>
@@ -3704,7 +3675,7 @@
                           <m:r>
                             <a:rPr lang="en-US" sz="4000" b="0">
                               <a:solidFill>
-                                <a:srgbClr val="1B2A3A"/>
+                                <a:srgbClr val="15241D"/>
                               </a:solidFill>
                               <a:latin typeface="Cambria Math"/>
                               <a:cs typeface="Cambria Math"/>
@@ -3744,439 +3715,7 @@
               <a:lstStyle/>
               <a:p>
                 <a:r>
-                  <a:t>i_D = \frac{1}{2} k_n' \frac{W}{L} (v_{GS}-V_t)^2</a:t>
-                </a:r>
-              </a:p>
-            </p:txBody>
-          </p:sp>
-        </mc:Fallback>
-      </mc:AlternateContent>
-      <mc:AlternateContent xmlns:mc="http://schemas.openxmlformats.org/markup-compatibility/2006">
-        <mc:Choice xmlns:a14="http://schemas.microsoft.com/office/drawing/2010/main" Requires="a14">
-          <p:sp>
-            <p:nvSpPr>
-              <p:cNvPr id="4" name="eq"/>
-              <p:cNvSpPr txBox="1"/>
-              <p:nvPr/>
-            </p:nvSpPr>
-            <p:spPr>
-              <a:xfrm>
-                <a:off x="1016000" y="6604000"/>
-                <a:ext cx="15240000" cy="1905000"/>
-              </a:xfrm>
-              <a:prstGeom prst="rect">
-                <a:avLst/>
-              </a:prstGeom>
-              <a:noFill/>
-            </p:spPr>
-            <p:txBody>
-              <a:bodyPr wrap="none">
-                <a:spAutoFit/>
-              </a:bodyPr>
-              <a:lstStyle/>
-              <a:p>
-                <a14:m>
-                  <m:oMathPara xmlns:m="http://schemas.openxmlformats.org/officeDocument/2006/math">
-                    <m:oMathParaPr>
-                      <m:jc m:val="left"/>
-                    </m:oMathParaPr>
-                    <m:oMath>
-                      <m:sSub>
-                        <m:e>
-                          <m:r>
-                            <a:rPr lang="en-US" sz="4000" b="0">
-                              <a:solidFill>
-                                <a:srgbClr val="1B2A3A"/>
-                              </a:solidFill>
-                              <a:latin typeface="Cambria Math"/>
-                              <a:cs typeface="Cambria Math"/>
-                            </a:rPr>
-                            <m:t>g</m:t>
-                          </m:r>
-                        </m:e>
-                        <m:sub>
-                          <m:r>
-                            <a:rPr lang="en-US" sz="4000" b="0">
-                              <a:solidFill>
-                                <a:srgbClr val="1B2A3A"/>
-                              </a:solidFill>
-                              <a:latin typeface="Cambria Math"/>
-                              <a:cs typeface="Cambria Math"/>
-                            </a:rPr>
-                            <m:t>m</m:t>
-                          </m:r>
-                        </m:sub>
-                      </m:sSub>
-                      <m:r>
-                        <a:rPr lang="en-US" sz="4000" b="0">
-                          <a:solidFill>
-                            <a:srgbClr val="1B2A3A"/>
-                          </a:solidFill>
-                          <a:latin typeface="Cambria Math"/>
-                          <a:cs typeface="Cambria Math"/>
-                        </a:rPr>
-                        <m:t>=</m:t>
-                      </m:r>
-                      <m:sSub>
-                        <m:e>
-                          <m:r>
-                            <a:rPr lang="en-US" sz="4000" b="0">
-                              <a:solidFill>
-                                <a:srgbClr val="1B2A3A"/>
-                              </a:solidFill>
-                              <a:latin typeface="Cambria Math"/>
-                              <a:cs typeface="Cambria Math"/>
-                            </a:rPr>
-                            <m:t/>
-                          </m:r>
-                          <m:f>
-                            <m:fPr>
-                              <m:type m:val="bar"/>
-                            </m:fPr>
-                            <m:num>
-                              <m:r>
-                                <a:rPr lang="en-US" sz="4000" b="0">
-                                  <a:solidFill>
-                                    <a:srgbClr val="1B2A3A"/>
-                                  </a:solidFill>
-                                  <a:latin typeface="Cambria Math"/>
-                                  <a:cs typeface="Cambria Math"/>
-                                </a:rPr>
-                                <m:t>∂</m:t>
-                              </m:r>
-                              <m:sSub>
-                                <m:e>
-                                  <m:r>
-                                    <a:rPr lang="en-US" sz="4000" b="0">
-                                      <a:solidFill>
-                                        <a:srgbClr val="1B2A3A"/>
-                                      </a:solidFill>
-                                      <a:latin typeface="Cambria Math"/>
-                                      <a:cs typeface="Cambria Math"/>
-                                    </a:rPr>
-                                    <m:t>i</m:t>
-                                  </m:r>
-                                </m:e>
-                                <m:sub>
-                                  <m:r>
-                                    <a:rPr lang="en-US" sz="4000" b="0">
-                                      <a:solidFill>
-                                        <a:srgbClr val="1B2A3A"/>
-                                      </a:solidFill>
-                                      <a:latin typeface="Cambria Math"/>
-                                      <a:cs typeface="Cambria Math"/>
-                                    </a:rPr>
-                                    <m:t>D</m:t>
-                                  </m:r>
-                                </m:sub>
-                              </m:sSub>
-                            </m:num>
-                            <m:den>
-                              <m:r>
-                                <a:rPr lang="en-US" sz="4000" b="0">
-                                  <a:solidFill>
-                                    <a:srgbClr val="1B2A3A"/>
-                                  </a:solidFill>
-                                  <a:latin typeface="Cambria Math"/>
-                                  <a:cs typeface="Cambria Math"/>
-                                </a:rPr>
-                                <m:t>∂</m:t>
-                              </m:r>
-                              <m:sSub>
-                                <m:e>
-                                  <m:r>
-                                    <a:rPr lang="en-US" sz="4000" b="0">
-                                      <a:solidFill>
-                                        <a:srgbClr val="1B2A3A"/>
-                                      </a:solidFill>
-                                      <a:latin typeface="Cambria Math"/>
-                                      <a:cs typeface="Cambria Math"/>
-                                    </a:rPr>
-                                    <m:t>v</m:t>
-                                  </m:r>
-                                </m:e>
-                                <m:sub>
-                                  <m:r>
-                                    <a:rPr lang="en-US" sz="4000" b="0">
-                                      <a:solidFill>
-                                        <a:srgbClr val="1B2A3A"/>
-                                      </a:solidFill>
-                                      <a:latin typeface="Cambria Math"/>
-                                      <a:cs typeface="Cambria Math"/>
-                                    </a:rPr>
-                                    <m:t>GS</m:t>
-                                  </m:r>
-                                </m:sub>
-                              </m:sSub>
-                            </m:den>
-                          </m:f>
-                          <m:r>
-                            <a:rPr lang="en-US" sz="4000" b="0">
-                              <a:solidFill>
-                                <a:srgbClr val="1B2A3A"/>
-                              </a:solidFill>
-                              <a:latin typeface="Cambria Math"/>
-                              <a:cs typeface="Cambria Math"/>
-                            </a:rPr>
-                            <m:t>|</m:t>
-                          </m:r>
-                        </m:e>
-                        <m:sub>
-                          <m:sSub>
-                            <m:e>
-                              <m:r>
-                                <a:rPr lang="en-US" sz="4000" b="0">
-                                  <a:solidFill>
-                                    <a:srgbClr val="1B2A3A"/>
-                                  </a:solidFill>
-                                  <a:latin typeface="Cambria Math"/>
-                                  <a:cs typeface="Cambria Math"/>
-                                </a:rPr>
-                                <m:t>v</m:t>
-                              </m:r>
-                            </m:e>
-                            <m:sub>
-                              <m:r>
-                                <a:rPr lang="en-US" sz="4000" b="0">
-                                  <a:solidFill>
-                                    <a:srgbClr val="1B2A3A"/>
-                                  </a:solidFill>
-                                  <a:latin typeface="Cambria Math"/>
-                                  <a:cs typeface="Cambria Math"/>
-                                </a:rPr>
-                                <m:t>GS</m:t>
-                              </m:r>
-                            </m:sub>
-                          </m:sSub>
-                          <m:r>
-                            <a:rPr lang="en-US" sz="4000" b="0">
-                              <a:solidFill>
-                                <a:srgbClr val="1B2A3A"/>
-                              </a:solidFill>
-                              <a:latin typeface="Cambria Math"/>
-                              <a:cs typeface="Cambria Math"/>
-                            </a:rPr>
-                            <m:t>=</m:t>
-                          </m:r>
-                          <m:sSub>
-                            <m:e>
-                              <m:r>
-                                <a:rPr lang="en-US" sz="4000" b="0">
-                                  <a:solidFill>
-                                    <a:srgbClr val="1B2A3A"/>
-                                  </a:solidFill>
-                                  <a:latin typeface="Cambria Math"/>
-                                  <a:cs typeface="Cambria Math"/>
-                                </a:rPr>
-                                <m:t>V</m:t>
-                              </m:r>
-                            </m:e>
-                            <m:sub>
-                              <m:r>
-                                <a:rPr lang="en-US" sz="4000" b="0">
-                                  <a:solidFill>
-                                    <a:srgbClr val="1B2A3A"/>
-                                  </a:solidFill>
-                                  <a:latin typeface="Cambria Math"/>
-                                  <a:cs typeface="Cambria Math"/>
-                                </a:rPr>
-                                <m:t>GS</m:t>
-                              </m:r>
-                            </m:sub>
-                          </m:sSub>
-                        </m:sub>
-                      </m:sSub>
-                      <m:r>
-                        <a:rPr lang="en-US" sz="4000" b="0">
-                          <a:solidFill>
-                            <a:srgbClr val="1B2A3A"/>
-                          </a:solidFill>
-                          <a:latin typeface="Cambria Math"/>
-                          <a:cs typeface="Cambria Math"/>
-                        </a:rPr>
-                        <m:t>=</m:t>
-                      </m:r>
-                      <m:sSubSup>
-                        <m:e>
-                          <m:r>
-                            <a:rPr lang="en-US" sz="4000" b="0">
-                              <a:solidFill>
-                                <a:srgbClr val="1B2A3A"/>
-                              </a:solidFill>
-                              <a:latin typeface="Cambria Math"/>
-                              <a:cs typeface="Cambria Math"/>
-                            </a:rPr>
-                            <m:t>k</m:t>
-                          </m:r>
-                        </m:e>
-                        <m:sub>
-                          <m:r>
-                            <a:rPr lang="en-US" sz="4000" b="0">
-                              <a:solidFill>
-                                <a:srgbClr val="1B2A3A"/>
-                              </a:solidFill>
-                              <a:latin typeface="Cambria Math"/>
-                              <a:cs typeface="Cambria Math"/>
-                            </a:rPr>
-                            <m:t>n</m:t>
-                          </m:r>
-                        </m:sub>
-                        <m:sup>
-                          <m:r>
-                            <a:rPr lang="en-US" sz="4000" b="0">
-                              <a:solidFill>
-                                <a:srgbClr val="1B2A3A"/>
-                              </a:solidFill>
-                              <a:latin typeface="Cambria Math"/>
-                              <a:cs typeface="Cambria Math"/>
-                            </a:rPr>
-                            <m:t>′</m:t>
-                          </m:r>
-                        </m:sup>
-                      </m:sSubSup>
-                      <m:f>
-                        <m:fPr>
-                          <m:type m:val="bar"/>
-                        </m:fPr>
-                        <m:num>
-                          <m:r>
-                            <a:rPr lang="en-US" sz="4000" b="0">
-                              <a:solidFill>
-                                <a:srgbClr val="1B2A3A"/>
-                              </a:solidFill>
-                              <a:latin typeface="Cambria Math"/>
-                              <a:cs typeface="Cambria Math"/>
-                            </a:rPr>
-                            <m:t>W</m:t>
-                          </m:r>
-                        </m:num>
-                        <m:den>
-                          <m:r>
-                            <a:rPr lang="en-US" sz="4000" b="0">
-                              <a:solidFill>
-                                <a:srgbClr val="1B2A3A"/>
-                              </a:solidFill>
-                              <a:latin typeface="Cambria Math"/>
-                              <a:cs typeface="Cambria Math"/>
-                            </a:rPr>
-                            <m:t>L</m:t>
-                          </m:r>
-                        </m:den>
-                      </m:f>
-                      <m:r>
-                        <a:rPr lang="en-US" sz="4000" b="0">
-                          <a:solidFill>
-                            <a:srgbClr val="1B2A3A"/>
-                          </a:solidFill>
-                          <a:latin typeface="Cambria Math"/>
-                          <a:cs typeface="Cambria Math"/>
-                        </a:rPr>
-                        <m:t>(</m:t>
-                      </m:r>
-                      <m:sSub>
-                        <m:e>
-                          <m:r>
-                            <a:rPr lang="en-US" sz="4000" b="0">
-                              <a:solidFill>
-                                <a:srgbClr val="1B2A3A"/>
-                              </a:solidFill>
-                              <a:latin typeface="Cambria Math"/>
-                              <a:cs typeface="Cambria Math"/>
-                            </a:rPr>
-                            <m:t>V</m:t>
-                          </m:r>
-                        </m:e>
-                        <m:sub>
-                          <m:r>
-                            <a:rPr lang="en-US" sz="4000" b="0">
-                              <a:solidFill>
-                                <a:srgbClr val="1B2A3A"/>
-                              </a:solidFill>
-                              <a:latin typeface="Cambria Math"/>
-                              <a:cs typeface="Cambria Math"/>
-                            </a:rPr>
-                            <m:t>GS</m:t>
-                          </m:r>
-                        </m:sub>
-                      </m:sSub>
-                      <m:r>
-                        <a:rPr lang="en-US" sz="4000" b="0">
-                          <a:solidFill>
-                            <a:srgbClr val="1B2A3A"/>
-                          </a:solidFill>
-                          <a:latin typeface="Cambria Math"/>
-                          <a:cs typeface="Cambria Math"/>
-                        </a:rPr>
-                        <m:t>−</m:t>
-                      </m:r>
-                      <m:sSub>
-                        <m:e>
-                          <m:r>
-                            <a:rPr lang="en-US" sz="4000" b="0">
-                              <a:solidFill>
-                                <a:srgbClr val="1B2A3A"/>
-                              </a:solidFill>
-                              <a:latin typeface="Cambria Math"/>
-                              <a:cs typeface="Cambria Math"/>
-                            </a:rPr>
-                            <m:t>V</m:t>
-                          </m:r>
-                        </m:e>
-                        <m:sub>
-                          <m:r>
-                            <a:rPr lang="en-US" sz="4000" b="0">
-                              <a:solidFill>
-                                <a:srgbClr val="1B2A3A"/>
-                              </a:solidFill>
-                              <a:latin typeface="Cambria Math"/>
-                              <a:cs typeface="Cambria Math"/>
-                            </a:rPr>
-                            <m:t>t</m:t>
-                          </m:r>
-                        </m:sub>
-                      </m:sSub>
-                      <m:r>
-                        <a:rPr lang="en-US" sz="4000" b="0">
-                          <a:solidFill>
-                            <a:srgbClr val="1B2A3A"/>
-                          </a:solidFill>
-                          <a:latin typeface="Cambria Math"/>
-                          <a:cs typeface="Cambria Math"/>
-                        </a:rPr>
-                        <m:t>)</m:t>
-                      </m:r>
-                    </m:oMath>
-                  </m:oMathPara>
-                </a14:m>
-              </a:p>
-            </p:txBody>
-          </p:sp>
-        </mc:Choice>
-        <mc:Fallback>
-          <p:sp>
-            <p:nvSpPr>
-              <p:cNvPr id="4" name="eq"/>
-              <p:cNvSpPr txBox="1"/>
-              <p:nvPr/>
-            </p:nvSpPr>
-            <p:spPr>
-              <a:xfrm>
-                <a:off x="1016000" y="6604000"/>
-                <a:ext cx="15240000" cy="1905000"/>
-              </a:xfrm>
-              <a:prstGeom prst="rect">
-                <a:avLst/>
-              </a:prstGeom>
-              <a:noFill/>
-            </p:spPr>
-            <p:txBody>
-              <a:bodyPr wrap="none">
-                <a:spAutoFit/>
-              </a:bodyPr>
-              <a:lstStyle/>
-              <a:p>
-                <a:r>
-                  <a:t>g_m = \left.\frac{\partial i_D}{\partial v_{GS}}\right|_{v_{GS}=V_{GS}} = k_n'\frac{W}{L}(V_{GS}-V_t)</a:t>
+                  <a:t>I_D = \frac{1}{2}\,\textcolor{#1E7A46}{1}\,(5-\textcolor{#7A3E9D}{6}I_D-\textcolor{#1E7A46}{1})^2</a:t>
                 </a:r>
               </a:p>
             </p:txBody>

</xml_diff>